<commit_message>
Run a cell with OpenAI's Codex as well as with Claude Code
scripts/2-runCell.sh takes --agent codex and drives codex exec against the same scenario
image over the same MCP server; codex-session-tokens.py writes the same usage.json from the
session rollout, so one analysis reads both agents. The default path is unchanged.

experiments/019-CodexSmoke has one smoke run per agent, what had to be discovered to make
Codex run non-interactively, and the two reasons a cross-agent comparison measures the
mechanism rather than the price.

Co-Authored-By: Claude Opus 5 <noreply@anthropic.com>
</commit_message>
<xml_diff>
--- a/ClaudeCode-Cuis-Experiments.pptx
+++ b/ClaudeCode-Cuis-Experiments.pptx
@@ -298,7 +298,7 @@
           <a:p>
             <a:fld id="{546698E6-1F87-3249-8548-2D03D268745A}" type="datetimeFigureOut">
               <a:rPr lang="en-AR" smtClean="0"/>
-              <a:t>16/09/2026</a:t>
+              <a:t>18/09/2026</a:t>
             </a:fld>
             <a:endParaRPr lang="en-AR"/>
           </a:p>
@@ -815,7 +815,7 @@
           <a:p>
             <a:fld id="{5BCAD085-E8A6-8845-BD4E-CB4CCA059FC4}" type="datetimeFigureOut">
               <a:rPr lang="en-US" smtClean="0"/>
-              <a:t>9/16/26</a:t>
+              <a:t>9/18/26</a:t>
             </a:fld>
             <a:endParaRPr lang="en-US"/>
           </a:p>
@@ -983,7 +983,7 @@
           <a:p>
             <a:fld id="{5BCAD085-E8A6-8845-BD4E-CB4CCA059FC4}" type="datetimeFigureOut">
               <a:rPr lang="en-US" smtClean="0"/>
-              <a:t>9/16/26</a:t>
+              <a:t>9/18/26</a:t>
             </a:fld>
             <a:endParaRPr lang="en-US"/>
           </a:p>
@@ -1161,7 +1161,7 @@
           <a:p>
             <a:fld id="{5BCAD085-E8A6-8845-BD4E-CB4CCA059FC4}" type="datetimeFigureOut">
               <a:rPr lang="en-US" smtClean="0"/>
-              <a:t>9/16/26</a:t>
+              <a:t>9/18/26</a:t>
             </a:fld>
             <a:endParaRPr lang="en-US"/>
           </a:p>
@@ -1329,7 +1329,7 @@
           <a:p>
             <a:fld id="{5BCAD085-E8A6-8845-BD4E-CB4CCA059FC4}" type="datetimeFigureOut">
               <a:rPr lang="en-US" smtClean="0"/>
-              <a:t>9/16/26</a:t>
+              <a:t>9/18/26</a:t>
             </a:fld>
             <a:endParaRPr lang="en-US"/>
           </a:p>
@@ -1574,7 +1574,7 @@
           <a:p>
             <a:fld id="{5BCAD085-E8A6-8845-BD4E-CB4CCA059FC4}" type="datetimeFigureOut">
               <a:rPr lang="en-US" smtClean="0"/>
-              <a:t>9/16/26</a:t>
+              <a:t>9/18/26</a:t>
             </a:fld>
             <a:endParaRPr lang="en-US"/>
           </a:p>
@@ -1859,7 +1859,7 @@
           <a:p>
             <a:fld id="{5BCAD085-E8A6-8845-BD4E-CB4CCA059FC4}" type="datetimeFigureOut">
               <a:rPr lang="en-US" smtClean="0"/>
-              <a:t>9/16/26</a:t>
+              <a:t>9/18/26</a:t>
             </a:fld>
             <a:endParaRPr lang="en-US"/>
           </a:p>
@@ -2278,7 +2278,7 @@
           <a:p>
             <a:fld id="{5BCAD085-E8A6-8845-BD4E-CB4CCA059FC4}" type="datetimeFigureOut">
               <a:rPr lang="en-US" smtClean="0"/>
-              <a:t>9/16/26</a:t>
+              <a:t>9/18/26</a:t>
             </a:fld>
             <a:endParaRPr lang="en-US"/>
           </a:p>
@@ -2395,7 +2395,7 @@
           <a:p>
             <a:fld id="{5BCAD085-E8A6-8845-BD4E-CB4CCA059FC4}" type="datetimeFigureOut">
               <a:rPr lang="en-US" smtClean="0"/>
-              <a:t>9/16/26</a:t>
+              <a:t>9/18/26</a:t>
             </a:fld>
             <a:endParaRPr lang="en-US"/>
           </a:p>
@@ -2490,7 +2490,7 @@
           <a:p>
             <a:fld id="{5BCAD085-E8A6-8845-BD4E-CB4CCA059FC4}" type="datetimeFigureOut">
               <a:rPr lang="en-US" smtClean="0"/>
-              <a:t>9/16/26</a:t>
+              <a:t>9/18/26</a:t>
             </a:fld>
             <a:endParaRPr lang="en-US"/>
           </a:p>
@@ -2765,7 +2765,7 @@
           <a:p>
             <a:fld id="{5BCAD085-E8A6-8845-BD4E-CB4CCA059FC4}" type="datetimeFigureOut">
               <a:rPr lang="en-US" smtClean="0"/>
-              <a:t>9/16/26</a:t>
+              <a:t>9/18/26</a:t>
             </a:fld>
             <a:endParaRPr lang="en-US"/>
           </a:p>
@@ -3017,7 +3017,7 @@
           <a:p>
             <a:fld id="{5BCAD085-E8A6-8845-BD4E-CB4CCA059FC4}" type="datetimeFigureOut">
               <a:rPr lang="en-US" smtClean="0"/>
-              <a:t>9/16/26</a:t>
+              <a:t>9/18/26</a:t>
             </a:fld>
             <a:endParaRPr lang="en-US"/>
           </a:p>
@@ -3228,7 +3228,7 @@
           <a:p>
             <a:fld id="{5BCAD085-E8A6-8845-BD4E-CB4CCA059FC4}" type="datetimeFigureOut">
               <a:rPr lang="en-US" smtClean="0"/>
-              <a:t>9/16/26</a:t>
+              <a:t>9/18/26</a:t>
             </a:fld>
             <a:endParaRPr lang="en-US"/>
           </a:p>
@@ -3686,7 +3686,7 @@
         <p:spPr>
           <a:xfrm>
             <a:off x="548640" y="4052149"/>
-            <a:ext cx="11094415" cy="584775"/>
+            <a:ext cx="11094415" cy="954107"/>
           </a:xfrm>
           <a:prstGeom prst="rect">
             <a:avLst/>
@@ -3709,6 +3709,93 @@
               </a:rPr>
               <a:t>Hernán Wilkinson</a:t>
             </a:r>
+            <a:endParaRPr lang="es-ES" sz="3200" dirty="0">
+              <a:solidFill>
+                <a:srgbClr val="666666"/>
+              </a:solidFill>
+              <a:latin typeface="Calibri"/>
+            </a:endParaRPr>
+          </a:p>
+          <a:p>
+            <a:pPr algn="ctr"/>
+            <a:r>
+              <a:rPr lang="en-US" sz="2400" dirty="0">
+                <a:solidFill>
+                  <a:srgbClr val="666666"/>
+                </a:solidFill>
+              </a:rPr>
+              <a:t>https://</a:t>
+            </a:r>
+            <a:r>
+              <a:rPr lang="en-US" sz="2400" dirty="0" err="1">
+                <a:solidFill>
+                  <a:srgbClr val="666666"/>
+                </a:solidFill>
+              </a:rPr>
+              <a:t>github.com</a:t>
+            </a:r>
+            <a:r>
+              <a:rPr lang="en-US" sz="2400" dirty="0">
+                <a:solidFill>
+                  <a:srgbClr val="666666"/>
+                </a:solidFill>
+              </a:rPr>
+              <a:t>/</a:t>
+            </a:r>
+            <a:r>
+              <a:rPr lang="en-US" sz="2400" dirty="0" err="1">
+                <a:solidFill>
+                  <a:srgbClr val="666666"/>
+                </a:solidFill>
+              </a:rPr>
+              <a:t>hernanwilkinson</a:t>
+            </a:r>
+            <a:r>
+              <a:rPr lang="en-US" sz="2400" dirty="0">
+                <a:solidFill>
+                  <a:srgbClr val="666666"/>
+                </a:solidFill>
+              </a:rPr>
+              <a:t>/</a:t>
+            </a:r>
+            <a:r>
+              <a:rPr lang="en-US" sz="2400" dirty="0" err="1">
+                <a:solidFill>
+                  <a:srgbClr val="666666"/>
+                </a:solidFill>
+              </a:rPr>
+              <a:t>ClaudeCode</a:t>
+            </a:r>
+            <a:r>
+              <a:rPr lang="en-US" sz="2400" dirty="0">
+                <a:solidFill>
+                  <a:srgbClr val="666666"/>
+                </a:solidFill>
+              </a:rPr>
+              <a:t>-</a:t>
+            </a:r>
+            <a:r>
+              <a:rPr lang="en-US" sz="2400" dirty="0" err="1">
+                <a:solidFill>
+                  <a:srgbClr val="666666"/>
+                </a:solidFill>
+              </a:rPr>
+              <a:t>CuisMCPServer</a:t>
+            </a:r>
+            <a:r>
+              <a:rPr lang="en-US" sz="2400" dirty="0">
+                <a:solidFill>
+                  <a:srgbClr val="666666"/>
+                </a:solidFill>
+              </a:rPr>
+              <a:t>-Experiments</a:t>
+            </a:r>
+            <a:endParaRPr sz="2400" dirty="0">
+              <a:solidFill>
+                <a:srgbClr val="666666"/>
+              </a:solidFill>
+              <a:latin typeface="Calibri"/>
+            </a:endParaRPr>
           </a:p>
         </p:txBody>
       </p:sp>
@@ -3774,6 +3861,13 @@
             <a:r>
               <a:rPr lang="en-AR" dirty="0"/>
               <a:t>Experimiento: Hacerlo todo con Claude Code</a:t>
+            </a:r>
+            <a:br>
+              <a:rPr lang="en-AR" dirty="0"/>
+            </a:br>
+            <a:r>
+              <a:rPr lang="en-AR" dirty="0"/>
+              <a:t>(pobre pibe que quería hacer la tesis 😞)</a:t>
             </a:r>
           </a:p>
         </p:txBody>
@@ -16230,7 +16324,7 @@
             </a:pPr>
             <a:r>
               <a:rPr lang="en-AR" sz="3200" dirty="0"/>
-              <a:t>Cada llamada a una herramienta es un request, y cada request reenvía toda la conversación</a:t>
+              <a:t>Cada llamada a una tool es un request, y cada request reenvía toda la conversación</a:t>
             </a:r>
           </a:p>
         </p:txBody>
@@ -27006,8 +27100,8 @@
         </p:nvSpPr>
         <p:spPr>
           <a:xfrm>
-            <a:off x="355600" y="1236133"/>
-            <a:ext cx="11573933" cy="3785652"/>
+            <a:off x="309033" y="920621"/>
+            <a:ext cx="11573933" cy="5016758"/>
           </a:xfrm>
           <a:prstGeom prst="rect">
             <a:avLst/>
@@ -27059,6 +27153,80 @@
             <a:r>
               <a:rPr lang="en-US" sz="4000" dirty="0"/>
               <a:t> el de un Ser Humano</a:t>
+            </a:r>
+          </a:p>
+          <a:p>
+            <a:pPr marL="285750" indent="-285750">
+              <a:buFont typeface="Arial" panose="020B0604020202020204" pitchFamily="34" charset="0"/>
+              <a:buChar char="•"/>
+            </a:pPr>
+            <a:r>
+              <a:rPr lang="en-US" sz="4000" dirty="0"/>
+              <a:t>Todo lo </a:t>
+            </a:r>
+            <a:r>
+              <a:rPr lang="en-US" sz="4000" dirty="0" err="1"/>
+              <a:t>que</a:t>
+            </a:r>
+            <a:r>
+              <a:rPr lang="en-US" sz="4000" dirty="0"/>
+              <a:t> </a:t>
+            </a:r>
+            <a:r>
+              <a:rPr lang="en-US" sz="4000" dirty="0" err="1"/>
+              <a:t>creemos</a:t>
+            </a:r>
+            <a:r>
+              <a:rPr lang="en-US" sz="4000" dirty="0"/>
+              <a:t> </a:t>
+            </a:r>
+            <a:r>
+              <a:rPr lang="en-US" sz="4000" dirty="0" err="1"/>
+              <a:t>que</a:t>
+            </a:r>
+            <a:r>
+              <a:rPr lang="en-US" sz="4000" dirty="0"/>
+              <a:t> </a:t>
+            </a:r>
+            <a:r>
+              <a:rPr lang="en-US" sz="4000" dirty="0" err="1"/>
+              <a:t>puede</a:t>
+            </a:r>
+            <a:r>
+              <a:rPr lang="en-US" sz="4000" dirty="0"/>
+              <a:t> ser bueno hay </a:t>
+            </a:r>
+            <a:r>
+              <a:rPr lang="en-US" sz="4000" dirty="0" err="1"/>
+              <a:t>que</a:t>
+            </a:r>
+            <a:r>
+              <a:rPr lang="en-US" sz="4000" dirty="0"/>
+              <a:t> </a:t>
+            </a:r>
+            <a:r>
+              <a:rPr lang="en-US" sz="4000" dirty="0" err="1"/>
+              <a:t>validarlo</a:t>
+            </a:r>
+            <a:r>
+              <a:rPr lang="en-US" sz="4000" dirty="0"/>
+              <a:t>, es </a:t>
+            </a:r>
+            <a:r>
+              <a:rPr lang="en-US" sz="4000" dirty="0" err="1"/>
+              <a:t>otro</a:t>
+            </a:r>
+            <a:r>
+              <a:rPr lang="en-US" sz="4000" dirty="0"/>
+              <a:t> “</a:t>
+            </a:r>
+            <a:r>
+              <a:rPr lang="en-US" sz="4000" dirty="0" err="1"/>
+              <a:t>paradigma</a:t>
+            </a:r>
+            <a:r>
+              <a:rPr lang="en-US" sz="4000" dirty="0"/>
+              <a:t>” </a:t>
             </a:r>
           </a:p>
           <a:p>

</xml_diff>